<commit_message>
Update presentation to include difficulties
</commit_message>
<xml_diff>
--- a/presentation/finale_präsentation_mobileGIS_G3.pptx
+++ b/presentation/finale_präsentation_mobileGIS_G3.pptx
@@ -6,7 +6,7 @@
     <p:sldMasterId id="2147483660" r:id="rId2"/>
   </p:sldMasterIdLst>
   <p:notesMasterIdLst>
-    <p:notesMasterId r:id="rId19"/>
+    <p:notesMasterId r:id="rId20"/>
   </p:notesMasterIdLst>
   <p:sldIdLst>
     <p:sldId id="347" r:id="rId3"/>
@@ -15,16 +15,17 @@
     <p:sldId id="350" r:id="rId6"/>
     <p:sldId id="351" r:id="rId7"/>
     <p:sldId id="352" r:id="rId8"/>
-    <p:sldId id="356" r:id="rId9"/>
-    <p:sldId id="354" r:id="rId10"/>
-    <p:sldId id="303" r:id="rId11"/>
-    <p:sldId id="259" r:id="rId12"/>
-    <p:sldId id="261" r:id="rId13"/>
-    <p:sldId id="304" r:id="rId14"/>
-    <p:sldId id="311" r:id="rId15"/>
-    <p:sldId id="345" r:id="rId16"/>
-    <p:sldId id="318" r:id="rId17"/>
-    <p:sldId id="307" r:id="rId18"/>
+    <p:sldId id="357" r:id="rId9"/>
+    <p:sldId id="356" r:id="rId10"/>
+    <p:sldId id="354" r:id="rId11"/>
+    <p:sldId id="303" r:id="rId12"/>
+    <p:sldId id="259" r:id="rId13"/>
+    <p:sldId id="261" r:id="rId14"/>
+    <p:sldId id="304" r:id="rId15"/>
+    <p:sldId id="311" r:id="rId16"/>
+    <p:sldId id="345" r:id="rId17"/>
+    <p:sldId id="318" r:id="rId18"/>
+    <p:sldId id="307" r:id="rId19"/>
   </p:sldIdLst>
   <p:sldSz cx="12192000" cy="6858000"/>
   <p:notesSz cx="6858000" cy="9144000"/>
@@ -3450,7 +3451,7 @@
           <a:p>
             <a:fld id="{BE3AC938-C7E8-444A-A4BB-EABBCAA0387F}" type="slidenum">
               <a:rPr lang="de-DE" smtClean="0"/>
-              <a:t>‹Nr.›</a:t>
+              <a:t>‹#›</a:t>
             </a:fld>
             <a:endParaRPr lang="de-DE" dirty="0"/>
           </a:p>
@@ -3619,7 +3620,7 @@
           <a:p>
             <a:fld id="{BE3AC938-C7E8-444A-A4BB-EABBCAA0387F}" type="slidenum">
               <a:rPr lang="de-DE" smtClean="0"/>
-              <a:t>7</a:t>
+              <a:t>8</a:t>
             </a:fld>
             <a:endParaRPr lang="de-DE" dirty="0"/>
           </a:p>
@@ -3703,7 +3704,7 @@
           <a:p>
             <a:fld id="{BE3AC938-C7E8-444A-A4BB-EABBCAA0387F}" type="slidenum">
               <a:rPr lang="de-DE" smtClean="0"/>
-              <a:t>10</a:t>
+              <a:t>11</a:t>
             </a:fld>
             <a:endParaRPr lang="de-DE" dirty="0"/>
           </a:p>
@@ -3782,7 +3783,7 @@
           <a:p>
             <a:fld id="{BE3AC938-C7E8-444A-A4BB-EABBCAA0387F}" type="slidenum">
               <a:rPr lang="de-DE" smtClean="0"/>
-              <a:t>11</a:t>
+              <a:t>12</a:t>
             </a:fld>
             <a:endParaRPr lang="de-DE" dirty="0"/>
           </a:p>
@@ -3861,7 +3862,7 @@
           <a:p>
             <a:fld id="{BE3AC938-C7E8-444A-A4BB-EABBCAA0387F}" type="slidenum">
               <a:rPr lang="de-DE" smtClean="0"/>
-              <a:t>12</a:t>
+              <a:t>13</a:t>
             </a:fld>
             <a:endParaRPr lang="de-DE" dirty="0"/>
           </a:p>
@@ -3940,7 +3941,7 @@
           <a:p>
             <a:fld id="{BE3AC938-C7E8-444A-A4BB-EABBCAA0387F}" type="slidenum">
               <a:rPr lang="de-DE" smtClean="0"/>
-              <a:t>13</a:t>
+              <a:t>14</a:t>
             </a:fld>
             <a:endParaRPr lang="de-DE" dirty="0"/>
           </a:p>
@@ -4019,7 +4020,7 @@
           <a:p>
             <a:fld id="{BE3AC938-C7E8-444A-A4BB-EABBCAA0387F}" type="slidenum">
               <a:rPr lang="de-DE" smtClean="0"/>
-              <a:t>14</a:t>
+              <a:t>15</a:t>
             </a:fld>
             <a:endParaRPr lang="de-DE" dirty="0"/>
           </a:p>
@@ -4098,7 +4099,7 @@
           <a:p>
             <a:fld id="{BE3AC938-C7E8-444A-A4BB-EABBCAA0387F}" type="slidenum">
               <a:rPr lang="de-DE" smtClean="0"/>
-              <a:t>15</a:t>
+              <a:t>16</a:t>
             </a:fld>
             <a:endParaRPr lang="de-DE" dirty="0"/>
           </a:p>
@@ -4177,7 +4178,7 @@
           <a:p>
             <a:fld id="{BE3AC938-C7E8-444A-A4BB-EABBCAA0387F}" type="slidenum">
               <a:rPr lang="de-DE" smtClean="0"/>
-              <a:t>16</a:t>
+              <a:t>17</a:t>
             </a:fld>
             <a:endParaRPr lang="de-DE" dirty="0"/>
           </a:p>
@@ -4366,7 +4367,7 @@
           <a:p>
             <a:fld id="{1152D26F-D91F-4BDA-B7C2-0B45ED53E507}" type="slidenum">
               <a:rPr lang="de-DE" smtClean="0"/>
-              <a:t>‹Nr.›</a:t>
+              <a:t>‹#›</a:t>
             </a:fld>
             <a:endParaRPr lang="de-DE" dirty="0"/>
           </a:p>
@@ -4533,7 +4534,7 @@
           <a:p>
             <a:fld id="{1152D26F-D91F-4BDA-B7C2-0B45ED53E507}" type="slidenum">
               <a:rPr lang="de-DE" smtClean="0"/>
-              <a:t>‹Nr.›</a:t>
+              <a:t>‹#›</a:t>
             </a:fld>
             <a:endParaRPr lang="de-DE" dirty="0"/>
           </a:p>
@@ -4710,7 +4711,7 @@
           <a:p>
             <a:fld id="{1152D26F-D91F-4BDA-B7C2-0B45ED53E507}" type="slidenum">
               <a:rPr lang="de-DE" smtClean="0"/>
-              <a:t>‹Nr.›</a:t>
+              <a:t>‹#›</a:t>
             </a:fld>
             <a:endParaRPr lang="de-DE" dirty="0"/>
           </a:p>
@@ -5793,7 +5794,7 @@
           <a:p>
             <a:fld id="{61696EC4-B4CF-4701-AD06-A8439D6D8E12}" type="slidenum">
               <a:rPr lang="en-US" noProof="0" smtClean="0"/>
-              <a:t>‹Nr.›</a:t>
+              <a:t>‹#›</a:t>
             </a:fld>
             <a:endParaRPr lang="en-US" noProof="0"/>
           </a:p>
@@ -6154,7 +6155,7 @@
           <a:p>
             <a:fld id="{61696EC4-B4CF-4701-AD06-A8439D6D8E12}" type="slidenum">
               <a:rPr lang="de-DE" smtClean="0"/>
-              <a:t>‹Nr.›</a:t>
+              <a:t>‹#›</a:t>
             </a:fld>
             <a:endParaRPr lang="de-DE"/>
           </a:p>
@@ -6445,7 +6446,7 @@
           <a:p>
             <a:fld id="{61696EC4-B4CF-4701-AD06-A8439D6D8E12}" type="slidenum">
               <a:rPr lang="de-DE" smtClean="0"/>
-              <a:t>‹Nr.›</a:t>
+              <a:t>‹#›</a:t>
             </a:fld>
             <a:endParaRPr lang="de-DE"/>
           </a:p>
@@ -6962,7 +6963,7 @@
           <a:p>
             <a:fld id="{61696EC4-B4CF-4701-AD06-A8439D6D8E12}" type="slidenum">
               <a:rPr lang="de-DE" smtClean="0"/>
-              <a:t>‹Nr.›</a:t>
+              <a:t>‹#›</a:t>
             </a:fld>
             <a:endParaRPr lang="de-DE"/>
           </a:p>
@@ -7409,7 +7410,7 @@
           <a:p>
             <a:fld id="{61696EC4-B4CF-4701-AD06-A8439D6D8E12}" type="slidenum">
               <a:rPr lang="de-DE" smtClean="0"/>
-              <a:t>‹Nr.›</a:t>
+              <a:t>‹#›</a:t>
             </a:fld>
             <a:endParaRPr lang="de-DE"/>
           </a:p>
@@ -7536,7 +7537,7 @@
           <a:p>
             <a:fld id="{61696EC4-B4CF-4701-AD06-A8439D6D8E12}" type="slidenum">
               <a:rPr lang="de-DE" smtClean="0"/>
-              <a:t>‹Nr.›</a:t>
+              <a:t>‹#›</a:t>
             </a:fld>
             <a:endParaRPr lang="de-DE"/>
           </a:p>
@@ -7759,7 +7760,7 @@
           <a:p>
             <a:fld id="{1152D26F-D91F-4BDA-B7C2-0B45ED53E507}" type="slidenum">
               <a:rPr lang="de-DE" smtClean="0"/>
-              <a:t>‹Nr.›</a:t>
+              <a:t>‹#›</a:t>
             </a:fld>
             <a:endParaRPr lang="de-DE" dirty="0"/>
           </a:p>
@@ -7830,7 +7831,7 @@
           <a:p>
             <a:fld id="{61696EC4-B4CF-4701-AD06-A8439D6D8E12}" type="slidenum">
               <a:rPr lang="de-DE" smtClean="0"/>
-              <a:t>‹Nr.›</a:t>
+              <a:t>‹#›</a:t>
             </a:fld>
             <a:endParaRPr lang="de-DE"/>
           </a:p>
@@ -8031,7 +8032,7 @@
           <a:p>
             <a:fld id="{61696EC4-B4CF-4701-AD06-A8439D6D8E12}" type="slidenum">
               <a:rPr lang="de-DE" smtClean="0"/>
-              <a:t>‹Nr.›</a:t>
+              <a:t>‹#›</a:t>
             </a:fld>
             <a:endParaRPr lang="de-DE"/>
           </a:p>
@@ -8158,7 +8159,7 @@
           <a:p>
             <a:fld id="{61696EC4-B4CF-4701-AD06-A8439D6D8E12}" type="slidenum">
               <a:rPr lang="de-DE" smtClean="0"/>
-              <a:t>‹Nr.›</a:t>
+              <a:t>‹#›</a:t>
             </a:fld>
             <a:endParaRPr lang="de-DE"/>
           </a:p>
@@ -8370,7 +8371,7 @@
           <a:p>
             <a:fld id="{61696EC4-B4CF-4701-AD06-A8439D6D8E12}" type="slidenum">
               <a:rPr lang="de-DE" smtClean="0"/>
-              <a:t>‹Nr.›</a:t>
+              <a:t>‹#›</a:t>
             </a:fld>
             <a:endParaRPr lang="de-DE"/>
           </a:p>
@@ -8571,7 +8572,7 @@
           <a:p>
             <a:fld id="{61696EC4-B4CF-4701-AD06-A8439D6D8E12}" type="slidenum">
               <a:rPr lang="de-DE" smtClean="0"/>
-              <a:t>‹Nr.›</a:t>
+              <a:t>‹#›</a:t>
             </a:fld>
             <a:endParaRPr lang="de-DE"/>
           </a:p>
@@ -8828,7 +8829,7 @@
           <a:p>
             <a:fld id="{61696EC4-B4CF-4701-AD06-A8439D6D8E12}" type="slidenum">
               <a:rPr lang="de-DE" smtClean="0"/>
-              <a:t>‹Nr.›</a:t>
+              <a:t>‹#›</a:t>
             </a:fld>
             <a:endParaRPr lang="de-DE"/>
           </a:p>
@@ -9019,7 +9020,7 @@
           <a:p>
             <a:fld id="{61696EC4-B4CF-4701-AD06-A8439D6D8E12}" type="slidenum">
               <a:rPr lang="de-DE" smtClean="0"/>
-              <a:t>‹Nr.›</a:t>
+              <a:t>‹#›</a:t>
             </a:fld>
             <a:endParaRPr lang="de-DE"/>
           </a:p>
@@ -9345,7 +9346,7 @@
           <a:p>
             <a:fld id="{61696EC4-B4CF-4701-AD06-A8439D6D8E12}" type="slidenum">
               <a:rPr lang="de-DE" smtClean="0"/>
-              <a:t>‹Nr.›</a:t>
+              <a:t>‹#›</a:t>
             </a:fld>
             <a:endParaRPr lang="de-DE"/>
           </a:p>
@@ -9632,7 +9633,7 @@
           <a:p>
             <a:fld id="{61696EC4-B4CF-4701-AD06-A8439D6D8E12}" type="slidenum">
               <a:rPr lang="de-DE" smtClean="0"/>
-              <a:t>‹Nr.›</a:t>
+              <a:t>‹#›</a:t>
             </a:fld>
             <a:endParaRPr lang="de-DE"/>
           </a:p>
@@ -9881,7 +9882,7 @@
           <a:p>
             <a:fld id="{1152D26F-D91F-4BDA-B7C2-0B45ED53E507}" type="slidenum">
               <a:rPr lang="de-DE" smtClean="0"/>
-              <a:t>‹Nr.›</a:t>
+              <a:t>‹#›</a:t>
             </a:fld>
             <a:endParaRPr lang="de-DE" dirty="0"/>
           </a:p>
@@ -10109,7 +10110,7 @@
           <a:p>
             <a:fld id="{1152D26F-D91F-4BDA-B7C2-0B45ED53E507}" type="slidenum">
               <a:rPr lang="de-DE" smtClean="0"/>
-              <a:t>‹Nr.›</a:t>
+              <a:t>‹#›</a:t>
             </a:fld>
             <a:endParaRPr lang="de-DE" dirty="0"/>
           </a:p>
@@ -10472,7 +10473,7 @@
           <a:p>
             <a:fld id="{1152D26F-D91F-4BDA-B7C2-0B45ED53E507}" type="slidenum">
               <a:rPr lang="de-DE" smtClean="0"/>
-              <a:t>‹Nr.›</a:t>
+              <a:t>‹#›</a:t>
             </a:fld>
             <a:endParaRPr lang="de-DE" dirty="0"/>
           </a:p>
@@ -10588,7 +10589,7 @@
           <a:p>
             <a:fld id="{1152D26F-D91F-4BDA-B7C2-0B45ED53E507}" type="slidenum">
               <a:rPr lang="de-DE" smtClean="0"/>
-              <a:t>‹Nr.›</a:t>
+              <a:t>‹#›</a:t>
             </a:fld>
             <a:endParaRPr lang="de-DE" dirty="0"/>
           </a:p>
@@ -10682,7 +10683,7 @@
           <a:p>
             <a:fld id="{1152D26F-D91F-4BDA-B7C2-0B45ED53E507}" type="slidenum">
               <a:rPr lang="de-DE" smtClean="0"/>
-              <a:t>‹Nr.›</a:t>
+              <a:t>‹#›</a:t>
             </a:fld>
             <a:endParaRPr lang="de-DE" dirty="0"/>
           </a:p>
@@ -10956,7 +10957,7 @@
           <a:p>
             <a:fld id="{1152D26F-D91F-4BDA-B7C2-0B45ED53E507}" type="slidenum">
               <a:rPr lang="de-DE" smtClean="0"/>
-              <a:t>‹Nr.›</a:t>
+              <a:t>‹#›</a:t>
             </a:fld>
             <a:endParaRPr lang="de-DE" dirty="0"/>
           </a:p>
@@ -11207,7 +11208,7 @@
           <a:p>
             <a:fld id="{1152D26F-D91F-4BDA-B7C2-0B45ED53E507}" type="slidenum">
               <a:rPr lang="de-DE" smtClean="0"/>
-              <a:t>‹Nr.›</a:t>
+              <a:t>‹#›</a:t>
             </a:fld>
             <a:endParaRPr lang="de-DE" dirty="0"/>
           </a:p>
@@ -11453,7 +11454,7 @@
           <a:p>
             <a:fld id="{1152D26F-D91F-4BDA-B7C2-0B45ED53E507}" type="slidenum">
               <a:rPr lang="de-DE" smtClean="0"/>
-              <a:t>‹Nr.›</a:t>
+              <a:t>‹#›</a:t>
             </a:fld>
             <a:endParaRPr lang="de-DE" dirty="0"/>
           </a:p>
@@ -11971,7 +11972,7 @@
             <a:fld id="{61696EC4-B4CF-4701-AD06-A8439D6D8E12}" type="slidenum">
               <a:rPr lang="en-US" smtClean="0"/>
               <a:pPr/>
-              <a:t>‹Nr.›</a:t>
+              <a:t>‹#›</a:t>
             </a:fld>
             <a:endParaRPr lang="en-US" dirty="0"/>
           </a:p>
@@ -12809,6 +12810,234 @@
 <file path=ppt/slides/slide10.xml><?xml version="1.0" encoding="utf-8"?>
 <p:sld xmlns:a="http://schemas.openxmlformats.org/drawingml/2006/main" xmlns:r="http://schemas.openxmlformats.org/officeDocument/2006/relationships" xmlns:p="http://schemas.openxmlformats.org/presentationml/2006/main" show="0">
   <p:cSld>
+    <p:spTree>
+      <p:nvGrpSpPr>
+        <p:cNvPr id="1" name=""/>
+        <p:cNvGrpSpPr/>
+        <p:nvPr/>
+      </p:nvGrpSpPr>
+      <p:grpSpPr>
+        <a:xfrm>
+          <a:off x="0" y="0"/>
+          <a:ext cx="0" cy="0"/>
+          <a:chOff x="0" y="0"/>
+          <a:chExt cx="0" cy="0"/>
+        </a:xfrm>
+      </p:grpSpPr>
+      <p:sp>
+        <p:nvSpPr>
+          <p:cNvPr id="2" name="Titel 1"/>
+          <p:cNvSpPr>
+            <a:spLocks noGrp="1"/>
+          </p:cNvSpPr>
+          <p:nvPr>
+            <p:ph type="ctrTitle"/>
+          </p:nvPr>
+        </p:nvSpPr>
+        <p:spPr>
+          <a:xfrm>
+            <a:off x="440267" y="1348141"/>
+            <a:ext cx="11232444" cy="2387600"/>
+          </a:xfrm>
+        </p:spPr>
+        <p:txBody>
+          <a:bodyPr/>
+          <a:lstStyle/>
+          <a:p>
+            <a:pPr algn="l"/>
+            <a:r>
+              <a:rPr lang="de-DE" dirty="0"/>
+              <a:t>Mobile GIS and LBS – </a:t>
+            </a:r>
+            <a:br>
+              <a:rPr lang="de-DE" dirty="0"/>
+            </a:br>
+            <a:r>
+              <a:rPr lang="de-DE" dirty="0"/>
+              <a:t>KIT Campus App</a:t>
+            </a:r>
+          </a:p>
+        </p:txBody>
+      </p:sp>
+      <p:sp>
+        <p:nvSpPr>
+          <p:cNvPr id="3" name="Untertitel 2"/>
+          <p:cNvSpPr>
+            <a:spLocks noGrp="1"/>
+          </p:cNvSpPr>
+          <p:nvPr>
+            <p:ph type="subTitle" idx="1"/>
+          </p:nvPr>
+        </p:nvSpPr>
+        <p:spPr>
+          <a:xfrm>
+            <a:off x="440267" y="3820137"/>
+            <a:ext cx="9144000" cy="1655762"/>
+          </a:xfrm>
+        </p:spPr>
+        <p:txBody>
+          <a:bodyPr>
+            <a:normAutofit/>
+          </a:bodyPr>
+          <a:lstStyle/>
+          <a:p>
+            <a:pPr algn="l"/>
+            <a:endParaRPr lang="en-US" dirty="0"/>
+          </a:p>
+          <a:p>
+            <a:pPr algn="l"/>
+            <a:r>
+              <a:rPr lang="en-US" sz="2200" dirty="0"/>
+              <a:t>Korvin Brecht; Jasmin Jährling; Elisabeth Kral;</a:t>
+            </a:r>
+            <a:r>
+              <a:rPr lang="de-DE" sz="2200" dirty="0"/>
+              <a:t> Merlin </a:t>
+            </a:r>
+            <a:r>
+              <a:rPr lang="de-DE" sz="2200" dirty="0" err="1"/>
+              <a:t>Pillich</a:t>
+            </a:r>
+            <a:endParaRPr lang="de-DE" sz="2200" dirty="0"/>
+          </a:p>
+          <a:p>
+            <a:pPr algn="l"/>
+            <a:r>
+              <a:rPr lang="de-DE" sz="2200" dirty="0"/>
+              <a:t>Mobile GIS &amp; LBS 2025 - Dr.-Ing. Paul Vincent Kuper</a:t>
+            </a:r>
+          </a:p>
+          <a:p>
+            <a:pPr algn="l"/>
+            <a:endParaRPr lang="en-US" dirty="0">
+              <a:hlinkClick r:id="rId2"/>
+            </a:endParaRPr>
+          </a:p>
+          <a:p>
+            <a:endParaRPr lang="de-DE" dirty="0"/>
+          </a:p>
+        </p:txBody>
+      </p:sp>
+      <p:pic>
+        <p:nvPicPr>
+          <p:cNvPr id="5" name="Grafik 4" descr="Ein Bild, das Schrift, Text, Grafiken, Logo enthält.&#10;&#10;KI-generierte Inhalte können fehlerhaft sein."/>
+          <p:cNvPicPr>
+            <a:picLocks noChangeAspect="1"/>
+          </p:cNvPicPr>
+          <p:nvPr/>
+        </p:nvPicPr>
+        <p:blipFill>
+          <a:blip r:embed="rId3">
+            <a:extLst>
+              <a:ext uri="{28A0092B-C50C-407E-A947-70E740481C1C}">
+                <a14:useLocalDpi xmlns:a14="http://schemas.microsoft.com/office/drawing/2010/main" val="0"/>
+              </a:ext>
+            </a:extLst>
+          </a:blip>
+          <a:stretch>
+            <a:fillRect/>
+          </a:stretch>
+        </p:blipFill>
+        <p:spPr>
+          <a:xfrm>
+            <a:off x="333251" y="402431"/>
+            <a:ext cx="2748616" cy="1255713"/>
+          </a:xfrm>
+          <a:prstGeom prst="rect">
+            <a:avLst/>
+          </a:prstGeom>
+        </p:spPr>
+      </p:pic>
+      <p:sp>
+        <p:nvSpPr>
+          <p:cNvPr id="6" name="Rechteck 5"/>
+          <p:cNvSpPr/>
+          <p:nvPr/>
+        </p:nvSpPr>
+        <p:spPr>
+          <a:xfrm>
+            <a:off x="333251" y="6309360"/>
+            <a:ext cx="11339460" cy="430403"/>
+          </a:xfrm>
+          <a:prstGeom prst="rect">
+            <a:avLst/>
+          </a:prstGeom>
+          <a:solidFill>
+            <a:srgbClr val="32A189"/>
+          </a:solidFill>
+          <a:ln>
+            <a:solidFill>
+              <a:schemeClr val="bg1">
+                <a:lumMod val="75000"/>
+              </a:schemeClr>
+            </a:solidFill>
+          </a:ln>
+        </p:spPr>
+        <p:style>
+          <a:lnRef idx="2">
+            <a:schemeClr val="accent1">
+              <a:shade val="15000"/>
+            </a:schemeClr>
+          </a:lnRef>
+          <a:fillRef idx="1">
+            <a:schemeClr val="accent1"/>
+          </a:fillRef>
+          <a:effectRef idx="0">
+            <a:schemeClr val="accent1"/>
+          </a:effectRef>
+          <a:fontRef idx="minor">
+            <a:schemeClr val="lt1"/>
+          </a:fontRef>
+        </p:style>
+        <p:txBody>
+          <a:bodyPr rtlCol="0" anchor="ctr"/>
+          <a:lstStyle/>
+          <a:p>
+            <a:pPr algn="ctr"/>
+            <a:endParaRPr lang="de-DE" dirty="0"/>
+          </a:p>
+        </p:txBody>
+      </p:sp>
+      <p:sp>
+        <p:nvSpPr>
+          <p:cNvPr id="8" name="Textfeld 7"/>
+          <p:cNvSpPr txBox="1"/>
+          <p:nvPr/>
+        </p:nvSpPr>
+        <p:spPr>
+          <a:xfrm>
+            <a:off x="333252" y="6393756"/>
+            <a:ext cx="4001682" cy="261610"/>
+          </a:xfrm>
+          <a:prstGeom prst="rect">
+            <a:avLst/>
+          </a:prstGeom>
+          <a:noFill/>
+        </p:spPr>
+        <p:txBody>
+          <a:bodyPr wrap="square" rtlCol="0">
+            <a:spAutoFit/>
+          </a:bodyPr>
+          <a:lstStyle/>
+          <a:p>
+            <a:r>
+              <a:rPr lang="de-DE" sz="1100" dirty="0"/>
+              <a:t>KIT – Die Forschungsuniversität der Helmholtz-Gemeinschaft</a:t>
+            </a:r>
+          </a:p>
+        </p:txBody>
+      </p:sp>
+    </p:spTree>
+  </p:cSld>
+  <p:clrMapOvr>
+    <a:masterClrMapping/>
+  </p:clrMapOvr>
+</p:sld>
+</file>
+
+<file path=ppt/slides/slide11.xml><?xml version="1.0" encoding="utf-8"?>
+<p:sld xmlns:a="http://schemas.openxmlformats.org/drawingml/2006/main" xmlns:r="http://schemas.openxmlformats.org/officeDocument/2006/relationships" xmlns:p="http://schemas.openxmlformats.org/presentationml/2006/main" show="0">
+  <p:cSld>
     <p:bg>
       <p:bgPr>
         <a:solidFill>
@@ -13417,7 +13646,7 @@
                   <a:schemeClr val="tx1"/>
                 </a:solidFill>
               </a:rPr>
-              <a:t>10</a:t>
+              <a:t>11</a:t>
             </a:fld>
             <a:endParaRPr lang="de-DE" dirty="0">
               <a:solidFill>
@@ -13514,7 +13743,7 @@
 </p:sld>
 </file>
 
-<file path=ppt/slides/slide11.xml><?xml version="1.0" encoding="utf-8"?>
+<file path=ppt/slides/slide12.xml><?xml version="1.0" encoding="utf-8"?>
 <p:sld xmlns:a="http://schemas.openxmlformats.org/drawingml/2006/main" xmlns:r="http://schemas.openxmlformats.org/officeDocument/2006/relationships" xmlns:p="http://schemas.openxmlformats.org/presentationml/2006/main" show="0">
   <p:cSld>
     <p:spTree>
@@ -13706,7 +13935,7 @@
                   <a:schemeClr val="tx1"/>
                 </a:solidFill>
               </a:rPr>
-              <a:t>11</a:t>
+              <a:t>12</a:t>
             </a:fld>
             <a:endParaRPr lang="de-DE" dirty="0">
               <a:solidFill>
@@ -13896,7 +14125,7 @@
 </p:sld>
 </file>
 
-<file path=ppt/slides/slide12.xml><?xml version="1.0" encoding="utf-8"?>
+<file path=ppt/slides/slide13.xml><?xml version="1.0" encoding="utf-8"?>
 <p:sld xmlns:a="http://schemas.openxmlformats.org/drawingml/2006/main" xmlns:r="http://schemas.openxmlformats.org/officeDocument/2006/relationships" xmlns:p="http://schemas.openxmlformats.org/presentationml/2006/main" show="0">
   <p:cSld>
     <p:spTree>
@@ -14083,7 +14312,7 @@
                   <a:schemeClr val="tx1"/>
                 </a:solidFill>
               </a:rPr>
-              <a:t>12</a:t>
+              <a:t>13</a:t>
             </a:fld>
             <a:endParaRPr lang="de-DE" dirty="0">
               <a:solidFill>
@@ -14242,7 +14471,7 @@
 </p:sld>
 </file>
 
-<file path=ppt/slides/slide13.xml><?xml version="1.0" encoding="utf-8"?>
+<file path=ppt/slides/slide14.xml><?xml version="1.0" encoding="utf-8"?>
 <p:sld xmlns:a="http://schemas.openxmlformats.org/drawingml/2006/main" xmlns:r="http://schemas.openxmlformats.org/officeDocument/2006/relationships" xmlns:p="http://schemas.openxmlformats.org/presentationml/2006/main" show="0">
   <p:cSld>
     <p:spTree>
@@ -14429,7 +14658,7 @@
                   <a:schemeClr val="tx1"/>
                 </a:solidFill>
               </a:rPr>
-              <a:t>13</a:t>
+              <a:t>14</a:t>
             </a:fld>
             <a:endParaRPr lang="de-DE" dirty="0">
               <a:solidFill>
@@ -14725,7 +14954,7 @@
 </p:sld>
 </file>
 
-<file path=ppt/slides/slide14.xml><?xml version="1.0" encoding="utf-8"?>
+<file path=ppt/slides/slide15.xml><?xml version="1.0" encoding="utf-8"?>
 <p:sld xmlns:a="http://schemas.openxmlformats.org/drawingml/2006/main" xmlns:r="http://schemas.openxmlformats.org/officeDocument/2006/relationships" xmlns:p="http://schemas.openxmlformats.org/presentationml/2006/main" show="0">
   <p:cSld>
     <p:spTree>
@@ -14912,7 +15141,7 @@
                   <a:schemeClr val="tx1"/>
                 </a:solidFill>
               </a:rPr>
-              <a:t>14</a:t>
+              <a:t>15</a:t>
             </a:fld>
             <a:endParaRPr lang="de-DE" dirty="0">
               <a:solidFill>
@@ -15135,7 +15364,7 @@
 </p:sld>
 </file>
 
-<file path=ppt/slides/slide15.xml><?xml version="1.0" encoding="utf-8"?>
+<file path=ppt/slides/slide16.xml><?xml version="1.0" encoding="utf-8"?>
 <p:sld xmlns:a="http://schemas.openxmlformats.org/drawingml/2006/main" xmlns:r="http://schemas.openxmlformats.org/officeDocument/2006/relationships" xmlns:p="http://schemas.openxmlformats.org/presentationml/2006/main" show="0">
   <p:cSld>
     <p:spTree>
@@ -15322,7 +15551,7 @@
                   <a:schemeClr val="tx1"/>
                 </a:solidFill>
               </a:rPr>
-              <a:t>15</a:t>
+              <a:t>16</a:t>
             </a:fld>
             <a:endParaRPr lang="de-DE" dirty="0">
               <a:solidFill>
@@ -15439,7 +15668,7 @@
 </p:sld>
 </file>
 
-<file path=ppt/slides/slide16.xml><?xml version="1.0" encoding="utf-8"?>
+<file path=ppt/slides/slide17.xml><?xml version="1.0" encoding="utf-8"?>
 <p:sld xmlns:a="http://schemas.openxmlformats.org/drawingml/2006/main" xmlns:r="http://schemas.openxmlformats.org/officeDocument/2006/relationships" xmlns:p="http://schemas.openxmlformats.org/presentationml/2006/main" show="0">
   <p:cSld>
     <p:spTree>
@@ -15626,7 +15855,7 @@
                   <a:schemeClr val="tx1"/>
                 </a:solidFill>
               </a:rPr>
-              <a:t>16</a:t>
+              <a:t>17</a:t>
             </a:fld>
             <a:endParaRPr lang="de-DE" dirty="0">
               <a:solidFill>
@@ -18285,6 +18514,209 @@
       </p:grpSpPr>
       <p:sp>
         <p:nvSpPr>
+          <p:cNvPr id="2" name="Content Placeholder 1">
+            <a:extLst>
+              <a:ext uri="{FF2B5EF4-FFF2-40B4-BE49-F238E27FC236}">
+                <a16:creationId xmlns:a16="http://schemas.microsoft.com/office/drawing/2014/main" id="{EE573E66-4FBF-9071-9AF1-5B318E8A6D42}"/>
+              </a:ext>
+            </a:extLst>
+          </p:cNvPr>
+          <p:cNvSpPr>
+            <a:spLocks noGrp="1"/>
+          </p:cNvSpPr>
+          <p:nvPr>
+            <p:ph idx="1"/>
+          </p:nvPr>
+        </p:nvSpPr>
+        <p:spPr>
+          <a:xfrm>
+            <a:off x="533400" y="1583512"/>
+            <a:ext cx="7750865" cy="4486472"/>
+          </a:xfrm>
+        </p:spPr>
+        <p:txBody>
+          <a:bodyPr/>
+          <a:lstStyle/>
+          <a:p>
+            <a:r>
+              <a:rPr lang="en-US" dirty="0"/>
+              <a:t>Cross-Origin Resource Sharing (CORS) Settings on WFS-Server</a:t>
+            </a:r>
+          </a:p>
+          <a:p>
+            <a:r>
+              <a:rPr lang="en-US" dirty="0"/>
+              <a:t>Fetching Files in JavaScript on iOS</a:t>
+            </a:r>
+          </a:p>
+          <a:p>
+            <a:r>
+              <a:rPr lang="en-US" dirty="0"/>
+              <a:t>Getting the Geolocation on iOS</a:t>
+            </a:r>
+          </a:p>
+          <a:p>
+            <a:r>
+              <a:rPr lang="en-US" dirty="0"/>
+              <a:t>UI experience when requesting location access inside a WebView on iOS</a:t>
+            </a:r>
+          </a:p>
+        </p:txBody>
+      </p:sp>
+      <p:sp>
+        <p:nvSpPr>
+          <p:cNvPr id="3" name="Date Placeholder 2">
+            <a:extLst>
+              <a:ext uri="{FF2B5EF4-FFF2-40B4-BE49-F238E27FC236}">
+                <a16:creationId xmlns:a16="http://schemas.microsoft.com/office/drawing/2014/main" id="{83BBD6EA-2D41-EC43-2BE1-EFA02B88EFD1}"/>
+              </a:ext>
+            </a:extLst>
+          </p:cNvPr>
+          <p:cNvSpPr>
+            <a:spLocks noGrp="1"/>
+          </p:cNvSpPr>
+          <p:nvPr>
+            <p:ph type="dt" sz="half" idx="10"/>
+          </p:nvPr>
+        </p:nvSpPr>
+        <p:spPr/>
+        <p:txBody>
+          <a:bodyPr/>
+          <a:lstStyle/>
+          <a:p>
+            <a:fld id="{0A9BFA6A-9A63-4E2D-92C0-C77BFA750EDB}" type="datetime1">
+              <a:rPr lang="de-DE" noProof="0" smtClean="0"/>
+              <a:t>24.07.2025</a:t>
+            </a:fld>
+            <a:endParaRPr lang="en-US" noProof="0"/>
+          </a:p>
+        </p:txBody>
+      </p:sp>
+      <p:sp>
+        <p:nvSpPr>
+          <p:cNvPr id="4" name="Slide Number Placeholder 3">
+            <a:extLst>
+              <a:ext uri="{FF2B5EF4-FFF2-40B4-BE49-F238E27FC236}">
+                <a16:creationId xmlns:a16="http://schemas.microsoft.com/office/drawing/2014/main" id="{6951B7A8-C5B4-2A90-C05B-323252718EC1}"/>
+              </a:ext>
+            </a:extLst>
+          </p:cNvPr>
+          <p:cNvSpPr>
+            <a:spLocks noGrp="1"/>
+          </p:cNvSpPr>
+          <p:nvPr>
+            <p:ph type="sldNum" sz="quarter" idx="12"/>
+          </p:nvPr>
+        </p:nvSpPr>
+        <p:spPr/>
+        <p:txBody>
+          <a:bodyPr/>
+          <a:lstStyle/>
+          <a:p>
+            <a:fld id="{61696EC4-B4CF-4701-AD06-A8439D6D8E12}" type="slidenum">
+              <a:rPr lang="en-US" noProof="0" smtClean="0"/>
+              <a:t>7</a:t>
+            </a:fld>
+            <a:endParaRPr lang="en-US" noProof="0"/>
+          </a:p>
+        </p:txBody>
+      </p:sp>
+      <p:sp>
+        <p:nvSpPr>
+          <p:cNvPr id="5" name="Title 4">
+            <a:extLst>
+              <a:ext uri="{FF2B5EF4-FFF2-40B4-BE49-F238E27FC236}">
+                <a16:creationId xmlns:a16="http://schemas.microsoft.com/office/drawing/2014/main" id="{A5621F79-81AD-88CC-B665-0B970D42CACC}"/>
+              </a:ext>
+            </a:extLst>
+          </p:cNvPr>
+          <p:cNvSpPr>
+            <a:spLocks noGrp="1"/>
+          </p:cNvSpPr>
+          <p:nvPr>
+            <p:ph type="title"/>
+          </p:nvPr>
+        </p:nvSpPr>
+        <p:spPr/>
+        <p:txBody>
+          <a:bodyPr/>
+          <a:lstStyle/>
+          <a:p>
+            <a:r>
+              <a:rPr lang="en-US" dirty="0"/>
+              <a:t>Difficulties</a:t>
+            </a:r>
+          </a:p>
+        </p:txBody>
+      </p:sp>
+      <p:pic>
+        <p:nvPicPr>
+          <p:cNvPr id="7" name="Picture 6" descr="A screen shot of a phone&#10;&#10;AI-generated content may be incorrect.">
+            <a:extLst>
+              <a:ext uri="{FF2B5EF4-FFF2-40B4-BE49-F238E27FC236}">
+                <a16:creationId xmlns:a16="http://schemas.microsoft.com/office/drawing/2014/main" id="{AE70A893-7807-E0DA-ECB4-61428E4B312A}"/>
+              </a:ext>
+            </a:extLst>
+          </p:cNvPr>
+          <p:cNvPicPr>
+            <a:picLocks noChangeAspect="1"/>
+          </p:cNvPicPr>
+          <p:nvPr/>
+        </p:nvPicPr>
+        <p:blipFill>
+          <a:blip r:embed="rId2" cstate="print">
+            <a:extLst>
+              <a:ext uri="{28A0092B-C50C-407E-A947-70E740481C1C}">
+                <a14:useLocalDpi xmlns:a14="http://schemas.microsoft.com/office/drawing/2010/main" val="0"/>
+              </a:ext>
+            </a:extLst>
+          </a:blip>
+          <a:stretch>
+            <a:fillRect/>
+          </a:stretch>
+        </p:blipFill>
+        <p:spPr>
+          <a:xfrm>
+            <a:off x="8724552" y="1162619"/>
+            <a:ext cx="2934048" cy="5106928"/>
+          </a:xfrm>
+          <a:prstGeom prst="rect">
+            <a:avLst/>
+          </a:prstGeom>
+        </p:spPr>
+      </p:pic>
+    </p:spTree>
+    <p:extLst>
+      <p:ext uri="{BB962C8B-B14F-4D97-AF65-F5344CB8AC3E}">
+        <p14:creationId xmlns:p14="http://schemas.microsoft.com/office/powerpoint/2010/main" val="1318366342"/>
+      </p:ext>
+    </p:extLst>
+  </p:cSld>
+  <p:clrMapOvr>
+    <a:masterClrMapping/>
+  </p:clrMapOvr>
+</p:sld>
+</file>
+
+<file path=ppt/slides/slide8.xml><?xml version="1.0" encoding="utf-8"?>
+<p:sld xmlns:a="http://schemas.openxmlformats.org/drawingml/2006/main" xmlns:r="http://schemas.openxmlformats.org/officeDocument/2006/relationships" xmlns:p="http://schemas.openxmlformats.org/presentationml/2006/main">
+  <p:cSld>
+    <p:spTree>
+      <p:nvGrpSpPr>
+        <p:cNvPr id="1" name=""/>
+        <p:cNvGrpSpPr/>
+        <p:nvPr/>
+      </p:nvGrpSpPr>
+      <p:grpSpPr>
+        <a:xfrm>
+          <a:off x="0" y="0"/>
+          <a:ext cx="0" cy="0"/>
+          <a:chOff x="0" y="0"/>
+          <a:chExt cx="0" cy="0"/>
+        </a:xfrm>
+      </p:grpSpPr>
+      <p:sp>
+        <p:nvSpPr>
           <p:cNvPr id="3" name="Inhaltsplatzhalter 2">
             <a:extLst>
               <a:ext uri="{FF2B5EF4-FFF2-40B4-BE49-F238E27FC236}">
@@ -18685,7 +19117,7 @@
           <a:p>
             <a:fld id="{61696EC4-B4CF-4701-AD06-A8439D6D8E12}" type="slidenum">
               <a:rPr lang="de-DE" smtClean="0"/>
-              <a:t>7</a:t>
+              <a:t>8</a:t>
             </a:fld>
             <a:endParaRPr lang="de-DE"/>
           </a:p>
@@ -18770,7 +19202,7 @@
 </p:sld>
 </file>
 
-<file path=ppt/slides/slide8.xml><?xml version="1.0" encoding="utf-8"?>
+<file path=ppt/slides/slide9.xml><?xml version="1.0" encoding="utf-8"?>
 <p:sld xmlns:a="http://schemas.openxmlformats.org/drawingml/2006/main" xmlns:r="http://schemas.openxmlformats.org/officeDocument/2006/relationships" xmlns:p="http://schemas.openxmlformats.org/presentationml/2006/main">
   <p:cSld>
     <p:spTree>
@@ -18999,7 +19431,7 @@
           <a:p>
             <a:fld id="{61696EC4-B4CF-4701-AD06-A8439D6D8E12}" type="slidenum">
               <a:rPr lang="en-US" noProof="0" smtClean="0"/>
-              <a:t>8</a:t>
+              <a:t>9</a:t>
             </a:fld>
             <a:endParaRPr lang="en-US" noProof="0"/>
           </a:p>
@@ -19040,234 +19472,6 @@
         <p14:creationId xmlns:p14="http://schemas.microsoft.com/office/powerpoint/2010/main" val="1227658728"/>
       </p:ext>
     </p:extLst>
-  </p:cSld>
-  <p:clrMapOvr>
-    <a:masterClrMapping/>
-  </p:clrMapOvr>
-</p:sld>
-</file>
-
-<file path=ppt/slides/slide9.xml><?xml version="1.0" encoding="utf-8"?>
-<p:sld xmlns:a="http://schemas.openxmlformats.org/drawingml/2006/main" xmlns:r="http://schemas.openxmlformats.org/officeDocument/2006/relationships" xmlns:p="http://schemas.openxmlformats.org/presentationml/2006/main" show="0">
-  <p:cSld>
-    <p:spTree>
-      <p:nvGrpSpPr>
-        <p:cNvPr id="1" name=""/>
-        <p:cNvGrpSpPr/>
-        <p:nvPr/>
-      </p:nvGrpSpPr>
-      <p:grpSpPr>
-        <a:xfrm>
-          <a:off x="0" y="0"/>
-          <a:ext cx="0" cy="0"/>
-          <a:chOff x="0" y="0"/>
-          <a:chExt cx="0" cy="0"/>
-        </a:xfrm>
-      </p:grpSpPr>
-      <p:sp>
-        <p:nvSpPr>
-          <p:cNvPr id="2" name="Titel 1"/>
-          <p:cNvSpPr>
-            <a:spLocks noGrp="1"/>
-          </p:cNvSpPr>
-          <p:nvPr>
-            <p:ph type="ctrTitle"/>
-          </p:nvPr>
-        </p:nvSpPr>
-        <p:spPr>
-          <a:xfrm>
-            <a:off x="440267" y="1348141"/>
-            <a:ext cx="11232444" cy="2387600"/>
-          </a:xfrm>
-        </p:spPr>
-        <p:txBody>
-          <a:bodyPr/>
-          <a:lstStyle/>
-          <a:p>
-            <a:pPr algn="l"/>
-            <a:r>
-              <a:rPr lang="de-DE" dirty="0"/>
-              <a:t>Mobile GIS and LBS – </a:t>
-            </a:r>
-            <a:br>
-              <a:rPr lang="de-DE" dirty="0"/>
-            </a:br>
-            <a:r>
-              <a:rPr lang="de-DE" dirty="0"/>
-              <a:t>KIT Campus App</a:t>
-            </a:r>
-          </a:p>
-        </p:txBody>
-      </p:sp>
-      <p:sp>
-        <p:nvSpPr>
-          <p:cNvPr id="3" name="Untertitel 2"/>
-          <p:cNvSpPr>
-            <a:spLocks noGrp="1"/>
-          </p:cNvSpPr>
-          <p:nvPr>
-            <p:ph type="subTitle" idx="1"/>
-          </p:nvPr>
-        </p:nvSpPr>
-        <p:spPr>
-          <a:xfrm>
-            <a:off x="440267" y="3820137"/>
-            <a:ext cx="9144000" cy="1655762"/>
-          </a:xfrm>
-        </p:spPr>
-        <p:txBody>
-          <a:bodyPr>
-            <a:normAutofit/>
-          </a:bodyPr>
-          <a:lstStyle/>
-          <a:p>
-            <a:pPr algn="l"/>
-            <a:endParaRPr lang="en-US" dirty="0"/>
-          </a:p>
-          <a:p>
-            <a:pPr algn="l"/>
-            <a:r>
-              <a:rPr lang="en-US" sz="2200" dirty="0"/>
-              <a:t>Korvin Brecht; Jasmin Jährling; Elisabeth Kral;</a:t>
-            </a:r>
-            <a:r>
-              <a:rPr lang="de-DE" sz="2200" dirty="0"/>
-              <a:t> Merlin </a:t>
-            </a:r>
-            <a:r>
-              <a:rPr lang="de-DE" sz="2200" dirty="0" err="1"/>
-              <a:t>Pillich</a:t>
-            </a:r>
-            <a:endParaRPr lang="de-DE" sz="2200" dirty="0"/>
-          </a:p>
-          <a:p>
-            <a:pPr algn="l"/>
-            <a:r>
-              <a:rPr lang="de-DE" sz="2200" dirty="0"/>
-              <a:t>Mobile GIS &amp; LBS 2025 - Dr.-Ing. Paul Vincent Kuper</a:t>
-            </a:r>
-          </a:p>
-          <a:p>
-            <a:pPr algn="l"/>
-            <a:endParaRPr lang="en-US" dirty="0">
-              <a:hlinkClick r:id="rId2"/>
-            </a:endParaRPr>
-          </a:p>
-          <a:p>
-            <a:endParaRPr lang="de-DE" dirty="0"/>
-          </a:p>
-        </p:txBody>
-      </p:sp>
-      <p:pic>
-        <p:nvPicPr>
-          <p:cNvPr id="5" name="Grafik 4" descr="Ein Bild, das Schrift, Text, Grafiken, Logo enthält.&#10;&#10;KI-generierte Inhalte können fehlerhaft sein."/>
-          <p:cNvPicPr>
-            <a:picLocks noChangeAspect="1"/>
-          </p:cNvPicPr>
-          <p:nvPr/>
-        </p:nvPicPr>
-        <p:blipFill>
-          <a:blip r:embed="rId3">
-            <a:extLst>
-              <a:ext uri="{28A0092B-C50C-407E-A947-70E740481C1C}">
-                <a14:useLocalDpi xmlns:a14="http://schemas.microsoft.com/office/drawing/2010/main" val="0"/>
-              </a:ext>
-            </a:extLst>
-          </a:blip>
-          <a:stretch>
-            <a:fillRect/>
-          </a:stretch>
-        </p:blipFill>
-        <p:spPr>
-          <a:xfrm>
-            <a:off x="333251" y="402431"/>
-            <a:ext cx="2748616" cy="1255713"/>
-          </a:xfrm>
-          <a:prstGeom prst="rect">
-            <a:avLst/>
-          </a:prstGeom>
-        </p:spPr>
-      </p:pic>
-      <p:sp>
-        <p:nvSpPr>
-          <p:cNvPr id="6" name="Rechteck 5"/>
-          <p:cNvSpPr/>
-          <p:nvPr/>
-        </p:nvSpPr>
-        <p:spPr>
-          <a:xfrm>
-            <a:off x="333251" y="6309360"/>
-            <a:ext cx="11339460" cy="430403"/>
-          </a:xfrm>
-          <a:prstGeom prst="rect">
-            <a:avLst/>
-          </a:prstGeom>
-          <a:solidFill>
-            <a:srgbClr val="32A189"/>
-          </a:solidFill>
-          <a:ln>
-            <a:solidFill>
-              <a:schemeClr val="bg1">
-                <a:lumMod val="75000"/>
-              </a:schemeClr>
-            </a:solidFill>
-          </a:ln>
-        </p:spPr>
-        <p:style>
-          <a:lnRef idx="2">
-            <a:schemeClr val="accent1">
-              <a:shade val="15000"/>
-            </a:schemeClr>
-          </a:lnRef>
-          <a:fillRef idx="1">
-            <a:schemeClr val="accent1"/>
-          </a:fillRef>
-          <a:effectRef idx="0">
-            <a:schemeClr val="accent1"/>
-          </a:effectRef>
-          <a:fontRef idx="minor">
-            <a:schemeClr val="lt1"/>
-          </a:fontRef>
-        </p:style>
-        <p:txBody>
-          <a:bodyPr rtlCol="0" anchor="ctr"/>
-          <a:lstStyle/>
-          <a:p>
-            <a:pPr algn="ctr"/>
-            <a:endParaRPr lang="de-DE" dirty="0"/>
-          </a:p>
-        </p:txBody>
-      </p:sp>
-      <p:sp>
-        <p:nvSpPr>
-          <p:cNvPr id="8" name="Textfeld 7"/>
-          <p:cNvSpPr txBox="1"/>
-          <p:nvPr/>
-        </p:nvSpPr>
-        <p:spPr>
-          <a:xfrm>
-            <a:off x="333252" y="6393756"/>
-            <a:ext cx="4001682" cy="261610"/>
-          </a:xfrm>
-          <a:prstGeom prst="rect">
-            <a:avLst/>
-          </a:prstGeom>
-          <a:noFill/>
-        </p:spPr>
-        <p:txBody>
-          <a:bodyPr wrap="square" rtlCol="0">
-            <a:spAutoFit/>
-          </a:bodyPr>
-          <a:lstStyle/>
-          <a:p>
-            <a:r>
-              <a:rPr lang="de-DE" sz="1100" dirty="0"/>
-              <a:t>KIT – Die Forschungsuniversität der Helmholtz-Gemeinschaft</a:t>
-            </a:r>
-          </a:p>
-        </p:txBody>
-      </p:sp>
-    </p:spTree>
   </p:cSld>
   <p:clrMapOvr>
     <a:masterClrMapping/>

</xml_diff>